<commit_message>
Expand migration decks with current feature surface
</commit_message>
<xml_diff>
--- a/docs/Tableau_to_PowerBI_Migration.pptx
+++ b/docs/Tableau_to_PowerBI_Migration.pptx
@@ -16,6 +16,7 @@
     <p:sldId id="264" r:id="rId15"/>
     <p:sldId id="265" r:id="rId16"/>
     <p:sldId id="266" r:id="rId17"/>
+    <p:sldId id="267" r:id="rId18"/>
   </p:sldIdLst>
   <p:sldSz cx="12191695" cy="6858000" type="screen4x3"/>
   <p:notesSz cx="6858000" cy="9144000"/>
@@ -3177,7 +3178,7 @@
                   <a:srgbClr val="F2C811"/>
                 </a:solidFill>
               </a:rPr>
-              <a:t>Automated Migration Tool</a:t>
+              <a:t>Evidence-Backed Migration Engine</a:t>
             </a:r>
           </a:p>
         </p:txBody>
@@ -3211,7 +3212,7 @@
                   <a:srgbClr val="FFFFFF"/>
                 </a:solidFill>
               </a:rPr>
-              <a:t>Migrate .twb/.twbx workbooks to .pbip projects — fully automated, zero manual rework</a:t>
+              <a:t>Migrate Tableau workbooks and Prep flows to PBIP and Fabric-ready artifacts</a:t>
             </a:r>
           </a:p>
         </p:txBody>
@@ -5305,6 +5306,472 @@
   <p:cSld>
     <p:bg>
       <p:bgPr>
+        <a:solidFill>
+          <a:srgbClr val="FFFFFF"/>
+        </a:solidFill>
+        <a:effectLst/>
+      </p:bgPr>
+    </p:bg>
+    <p:spTree>
+      <p:nvGrpSpPr>
+        <p:cNvPr id="1" name=""/>
+        <p:cNvGrpSpPr/>
+        <p:nvPr/>
+      </p:nvGrpSpPr>
+      <p:grpSpPr/>
+      <p:sp>
+        <p:nvSpPr>
+          <p:cNvPr id="2" name="TextBox 1"/>
+          <p:cNvSpPr txBox="1"/>
+          <p:nvPr/>
+        </p:nvSpPr>
+        <p:spPr>
+          <a:xfrm>
+            <a:off x="457200" y="274320"/>
+            <a:ext cx="10972800" cy="640080"/>
+          </a:xfrm>
+          <a:prstGeom prst="rect">
+            <a:avLst/>
+          </a:prstGeom>
+          <a:noFill/>
+        </p:spPr>
+        <p:txBody>
+          <a:bodyPr wrap="square">
+            <a:spAutoFit/>
+          </a:bodyPr>
+          <a:lstStyle/>
+          <a:p>
+            <a:pPr algn="l"/>
+            <a:r>
+              <a:rPr sz="3000" b="1">
+                <a:solidFill>
+                  <a:srgbClr val="004578"/>
+                </a:solidFill>
+              </a:rPr>
+              <a:t>Operational Surfaces — From Developer Tool to Handoff</a:t>
+            </a:r>
+          </a:p>
+        </p:txBody>
+      </p:sp>
+      <p:sp>
+        <p:nvSpPr>
+          <p:cNvPr id="3" name="Rounded Rectangle 2"/>
+          <p:cNvSpPr/>
+          <p:nvPr/>
+        </p:nvSpPr>
+        <p:spPr>
+          <a:xfrm>
+            <a:off x="457200" y="1234440"/>
+            <a:ext cx="3611880" cy="1554480"/>
+          </a:xfrm>
+          <a:prstGeom prst="roundRect">
+            <a:avLst/>
+          </a:prstGeom>
+          <a:solidFill>
+            <a:srgbClr val="0078D4"/>
+          </a:solidFill>
+          <a:ln>
+            <a:noFill/>
+          </a:ln>
+        </p:spPr>
+        <p:style>
+          <a:lnRef idx="1">
+            <a:schemeClr val="accent1"/>
+          </a:lnRef>
+          <a:fillRef idx="3">
+            <a:schemeClr val="accent1"/>
+          </a:fillRef>
+          <a:effectRef idx="2">
+            <a:schemeClr val="accent1"/>
+          </a:effectRef>
+          <a:fontRef idx="minor">
+            <a:schemeClr val="lt1"/>
+          </a:fontRef>
+        </p:style>
+        <p:txBody>
+          <a:bodyPr rtlCol="0" anchor="ctr" wrap="square"/>
+          <a:lstStyle/>
+          <a:p>
+            <a:pPr algn="ctr">
+              <a:spcBef>
+                <a:spcPts val="0"/>
+              </a:spcBef>
+              <a:spcAft>
+                <a:spcPts val="0"/>
+              </a:spcAft>
+            </a:pPr>
+            <a:r>
+              <a:rPr sz="1200" b="0">
+                <a:solidFill>
+                  <a:srgbClr val="FFFFFF"/>
+                </a:solidFill>
+              </a:rPr>
+              <a:t>Developer surfaces
+VS Code extension
+Notebook API v2
+DAX/Tableau syntax grammars
+Plugin SDK + marketplace</a:t>
+            </a:r>
+          </a:p>
+        </p:txBody>
+      </p:sp>
+      <p:sp>
+        <p:nvSpPr>
+          <p:cNvPr id="4" name="Rounded Rectangle 3"/>
+          <p:cNvSpPr/>
+          <p:nvPr/>
+        </p:nvSpPr>
+        <p:spPr>
+          <a:xfrm>
+            <a:off x="4343400" y="1234440"/>
+            <a:ext cx="3611880" cy="1554480"/>
+          </a:xfrm>
+          <a:prstGeom prst="roundRect">
+            <a:avLst/>
+          </a:prstGeom>
+          <a:solidFill>
+            <a:srgbClr val="8764B8"/>
+          </a:solidFill>
+          <a:ln>
+            <a:noFill/>
+          </a:ln>
+        </p:spPr>
+        <p:style>
+          <a:lnRef idx="1">
+            <a:schemeClr val="accent1"/>
+          </a:lnRef>
+          <a:fillRef idx="3">
+            <a:schemeClr val="accent1"/>
+          </a:fillRef>
+          <a:effectRef idx="2">
+            <a:schemeClr val="accent1"/>
+          </a:effectRef>
+          <a:fontRef idx="minor">
+            <a:schemeClr val="lt1"/>
+          </a:fontRef>
+        </p:style>
+        <p:txBody>
+          <a:bodyPr rtlCol="0" anchor="ctr" wrap="square"/>
+          <a:lstStyle/>
+          <a:p>
+            <a:pPr algn="ctr">
+              <a:spcBef>
+                <a:spcPts val="0"/>
+              </a:spcBef>
+              <a:spcAft>
+                <a:spcPts val="0"/>
+              </a:spcAft>
+            </a:pPr>
+            <a:r>
+              <a:rPr sz="1200" b="0">
+                <a:solidFill>
+                  <a:srgbClr val="FFFFFF"/>
+                </a:solidFill>
+              </a:rPr>
+              <a:t>Agent surfaces
+Copilot skill + flag reference
+MCP tools: assess, migrate, QA, parity
+Grounded remediation and Q&amp;A
+Secret-safe deployment guardrails</a:t>
+            </a:r>
+          </a:p>
+        </p:txBody>
+      </p:sp>
+      <p:sp>
+        <p:nvSpPr>
+          <p:cNvPr id="5" name="Rounded Rectangle 4"/>
+          <p:cNvSpPr/>
+          <p:nvPr/>
+        </p:nvSpPr>
+        <p:spPr>
+          <a:xfrm>
+            <a:off x="8229600" y="1234440"/>
+            <a:ext cx="3611880" cy="1554480"/>
+          </a:xfrm>
+          <a:prstGeom prst="roundRect">
+            <a:avLst/>
+          </a:prstGeom>
+          <a:solidFill>
+            <a:srgbClr val="038387"/>
+          </a:solidFill>
+          <a:ln>
+            <a:noFill/>
+          </a:ln>
+        </p:spPr>
+        <p:style>
+          <a:lnRef idx="1">
+            <a:schemeClr val="accent1"/>
+          </a:lnRef>
+          <a:fillRef idx="3">
+            <a:schemeClr val="accent1"/>
+          </a:fillRef>
+          <a:effectRef idx="2">
+            <a:schemeClr val="accent1"/>
+          </a:effectRef>
+          <a:fontRef idx="minor">
+            <a:schemeClr val="lt1"/>
+          </a:fontRef>
+        </p:style>
+        <p:txBody>
+          <a:bodyPr rtlCol="0" anchor="ctr" wrap="square"/>
+          <a:lstStyle/>
+          <a:p>
+            <a:pPr algn="ctr">
+              <a:spcBef>
+                <a:spcPts val="0"/>
+              </a:spcBef>
+              <a:spcAft>
+                <a:spcPts val="0"/>
+              </a:spcAft>
+            </a:pPr>
+            <a:r>
+              <a:rPr sz="1200" b="0">
+                <a:solidFill>
+                  <a:srgbClr val="FFFFFF"/>
+                </a:solidFill>
+              </a:rPr>
+              <a:t>Enterprise surfaces
+Tableau Server/Cloud download
+Portfolio assessment and lineage
+Prep-flow analysis
+OAuth, gateway, RLS and credentials templates</a:t>
+            </a:r>
+          </a:p>
+        </p:txBody>
+      </p:sp>
+      <p:sp>
+        <p:nvSpPr>
+          <p:cNvPr id="6" name="Rounded Rectangle 5"/>
+          <p:cNvSpPr/>
+          <p:nvPr/>
+        </p:nvSpPr>
+        <p:spPr>
+          <a:xfrm>
+            <a:off x="457200" y="3063240"/>
+            <a:ext cx="3611880" cy="1554480"/>
+          </a:xfrm>
+          <a:prstGeom prst="roundRect">
+            <a:avLst/>
+          </a:prstGeom>
+          <a:solidFill>
+            <a:srgbClr val="107C10"/>
+          </a:solidFill>
+          <a:ln>
+            <a:noFill/>
+          </a:ln>
+        </p:spPr>
+        <p:style>
+          <a:lnRef idx="1">
+            <a:schemeClr val="accent1"/>
+          </a:lnRef>
+          <a:fillRef idx="3">
+            <a:schemeClr val="accent1"/>
+          </a:fillRef>
+          <a:effectRef idx="2">
+            <a:schemeClr val="accent1"/>
+          </a:effectRef>
+          <a:fontRef idx="minor">
+            <a:schemeClr val="lt1"/>
+          </a:fontRef>
+        </p:style>
+        <p:txBody>
+          <a:bodyPr rtlCol="0" anchor="ctr" wrap="square"/>
+          <a:lstStyle/>
+          <a:p>
+            <a:pPr algn="ctr">
+              <a:spcBef>
+                <a:spcPts val="0"/>
+              </a:spcBef>
+              <a:spcAft>
+                <a:spcPts val="0"/>
+              </a:spcAft>
+            </a:pPr>
+            <a:r>
+              <a:rPr sz="1200" b="0">
+                <a:solidFill>
+                  <a:srgbClr val="FFFFFF"/>
+                </a:solidFill>
+              </a:rPr>
+              <a:t>Quality surfaces
+Openability and Desktop probe
+Self-healing and recovery ledger
+Visual/data/interface fidelity
+Evidence manifest and policy profiles</a:t>
+            </a:r>
+          </a:p>
+        </p:txBody>
+      </p:sp>
+      <p:sp>
+        <p:nvSpPr>
+          <p:cNvPr id="7" name="Rounded Rectangle 6"/>
+          <p:cNvSpPr/>
+          <p:nvPr/>
+        </p:nvSpPr>
+        <p:spPr>
+          <a:xfrm>
+            <a:off x="4343400" y="3063240"/>
+            <a:ext cx="3611880" cy="1554480"/>
+          </a:xfrm>
+          <a:prstGeom prst="roundRect">
+            <a:avLst/>
+          </a:prstGeom>
+          <a:solidFill>
+            <a:srgbClr val="004578"/>
+          </a:solidFill>
+          <a:ln>
+            <a:noFill/>
+          </a:ln>
+        </p:spPr>
+        <p:style>
+          <a:lnRef idx="1">
+            <a:schemeClr val="accent1"/>
+          </a:lnRef>
+          <a:fillRef idx="3">
+            <a:schemeClr val="accent1"/>
+          </a:fillRef>
+          <a:effectRef idx="2">
+            <a:schemeClr val="accent1"/>
+          </a:effectRef>
+          <a:fontRef idx="minor">
+            <a:schemeClr val="lt1"/>
+          </a:fontRef>
+        </p:style>
+        <p:txBody>
+          <a:bodyPr rtlCol="0" anchor="ctr" wrap="square"/>
+          <a:lstStyle/>
+          <a:p>
+            <a:pPr algn="ctr">
+              <a:spcBef>
+                <a:spcPts val="0"/>
+              </a:spcBef>
+              <a:spcAft>
+                <a:spcPts val="0"/>
+              </a:spcAft>
+            </a:pPr>
+            <a:r>
+              <a:rPr sz="1200" b="0">
+                <a:solidFill>
+                  <a:srgbClr val="FFFFFF"/>
+                </a:solidFill>
+              </a:rPr>
+              <a:t>Delivery surfaces
+PBIP/PBIR/TMDL output
+Fabric six-artifact scaffold
+PDF/PPTX/report packages
+Power BI Service and Fabric deployment</a:t>
+            </a:r>
+          </a:p>
+        </p:txBody>
+      </p:sp>
+      <p:sp>
+        <p:nvSpPr>
+          <p:cNvPr id="8" name="Rounded Rectangle 7"/>
+          <p:cNvSpPr/>
+          <p:nvPr/>
+        </p:nvSpPr>
+        <p:spPr>
+          <a:xfrm>
+            <a:off x="8229600" y="3063240"/>
+            <a:ext cx="3611880" cy="1554480"/>
+          </a:xfrm>
+          <a:prstGeom prst="roundRect">
+            <a:avLst/>
+          </a:prstGeom>
+          <a:solidFill>
+            <a:srgbClr val="A4262C"/>
+          </a:solidFill>
+          <a:ln>
+            <a:noFill/>
+          </a:ln>
+        </p:spPr>
+        <p:style>
+          <a:lnRef idx="1">
+            <a:schemeClr val="accent1"/>
+          </a:lnRef>
+          <a:fillRef idx="3">
+            <a:schemeClr val="accent1"/>
+          </a:fillRef>
+          <a:effectRef idx="2">
+            <a:schemeClr val="accent1"/>
+          </a:effectRef>
+          <a:fontRef idx="minor">
+            <a:schemeClr val="lt1"/>
+          </a:fontRef>
+        </p:style>
+        <p:txBody>
+          <a:bodyPr rtlCol="0" anchor="ctr" wrap="square"/>
+          <a:lstStyle/>
+          <a:p>
+            <a:pPr algn="ctr">
+              <a:spcBef>
+                <a:spcPts val="0"/>
+              </a:spcBef>
+              <a:spcAft>
+                <a:spcPts val="0"/>
+              </a:spcAft>
+            </a:pPr>
+            <a:r>
+              <a:rPr sz="1200" b="0">
+                <a:solidFill>
+                  <a:srgbClr val="FFFFFF"/>
+                </a:solidFill>
+              </a:rPr>
+              <a:t>Safety boundary
+Local status is static unless runtime evidence exists
+Semantic execution defaults to not_run
+AI suggests; deterministic validators decide
+Credentials and customer data stay out of fixtures</a:t>
+            </a:r>
+          </a:p>
+        </p:txBody>
+      </p:sp>
+      <p:sp>
+        <p:nvSpPr>
+          <p:cNvPr id="9" name="TextBox 8"/>
+          <p:cNvSpPr txBox="1"/>
+          <p:nvPr/>
+        </p:nvSpPr>
+        <p:spPr>
+          <a:xfrm>
+            <a:off x="457200" y="5166360"/>
+            <a:ext cx="10972800" cy="640080"/>
+          </a:xfrm>
+          <a:prstGeom prst="rect">
+            <a:avLst/>
+          </a:prstGeom>
+          <a:noFill/>
+        </p:spPr>
+        <p:txBody>
+          <a:bodyPr wrap="square">
+            <a:spAutoFit/>
+          </a:bodyPr>
+          <a:lstStyle/>
+          <a:p>
+            <a:pPr algn="ctr"/>
+            <a:r>
+              <a:rPr sz="1600" b="1">
+                <a:solidFill>
+                  <a:srgbClr val="004578"/>
+                </a:solidFill>
+              </a:rPr>
+              <a:t>One versioned evidence contract connects CLI, batch, MCP, Notebook, VS Code, and Fabric metadata.</a:t>
+            </a:r>
+          </a:p>
+        </p:txBody>
+      </p:sp>
+    </p:spTree>
+  </p:cSld>
+  <p:clrMapOvr>
+    <a:masterClrMapping/>
+  </p:clrMapOvr>
+</p:sld>
+</file>
+
+<file path=ppt/slides/slide12.xml><?xml version="1.0" encoding="utf-8"?>
+<p:sld xmlns:a="http://schemas.openxmlformats.org/drawingml/2006/main" xmlns:p="http://schemas.openxmlformats.org/presentationml/2006/main" xmlns:r="http://schemas.openxmlformats.org/officeDocument/2006/relationships">
+  <p:cSld>
+    <p:bg>
+      <p:bgPr>
         <a:gradFill rotWithShape="1">
           <a:gsLst>
             <a:gs pos="0">
@@ -6918,7 +7385,7 @@
                   <a:srgbClr val="605E5C"/>
                 </a:solidFill>
               </a:rPr>
-              <a:t>Zero external dependencies • Zero manual rework on standard workbooks • Enterprise-grade security (OWASP Top 10) • Full audit trail &amp; governance</a:t>
+              <a:t>Static validation is deterministic • Live Desktop/Fabric evidence is explicit • Every approximation and blocker remains visible</a:t>
             </a:r>
           </a:p>
         </p:txBody>

</xml_diff>

<commit_message>
Prefer native database sources over Hyper and preserve field lineage
Restore explicit column ownership and complete public sample metadata. Select eligible native database bindings before Hyper export, preserve complete exports for remaining consumers, and keep physical-to-local-to-caption bindings consistent across M, TMDL and PBIR. Add regression coverage and update documentation and presentations.

Co-authored-by: Copilot <223556219+Copilot@users.noreply.github.com>
</commit_message>
<xml_diff>
--- a/docs/Tableau_to_PowerBI_Migration.pptx
+++ b/docs/Tableau_to_PowerBI_Migration.pptx
@@ -1415,7 +1415,7 @@
           </a:p>
           <a:p>
             <a:r>
-              <a:t>Hyper &lt;= 10 * 1024 * 1024 octets : CSV + Import. Strictement au-dessus : Parquet natif + Import, SDK Hyper optionnel requis. Sans Hyper, DirectQuery si le connecteur le permet, sinon Import. L'utilisateur peut forcer Import. L'Import natif ne déclenche aucune extraction/copie de lignes par l'outil. Exception explicite : un classeur Excel réellement embarqué dans le TWBX est copié sans modification dans Data/ et lié par chemin absolu ; ce n'est pas une extraction de lignes, elle ne couvre ni les jobs téléversés ni les modèles partagés, et le chemin absolu local figure dans le projet. Fabric conserve un contrat de staging distinct.</a:t>
+              <a:t>Si une même source déclare Hyper et une base d’origine explicite, complète et non ambiguë, retenir cette base avant toute lecture/export Hyper. Ne pas deviner une base depuis Excel/CSV ou une référence publiée non résolue. Un lien de base incomplet ou ambigu est une erreur explicite. Hyper conservé &lt;= 10 * 1024 * 1024 octets : CSV + Import. Strictement au-dessus : Parquet natif + Import, SDK Hyper optionnel requis. Base native : DirectQuery si le connecteur le permet, sinon Import. L'utilisateur peut forcer Import sans changer la source retenue. Aucune connexion à la base pendant la génération ; pas de garantie de parité avec un extrait filtré, agrégé ou daté. L'Import natif ne déclenche aucune extraction/copie de lignes par l'outil. Exception explicite : un classeur Excel réellement embarqué dans le TWBX est copié sans modification dans Data/ et lié par chemin absolu ; ce n'est pas une extraction de lignes, elle ne couvre ni les jobs téléversés ni les modèles partagés, et le chemin absolu local figure dans le projet. Fabric conserve un contrat de staging distinct.</a:t>
             </a:r>
           </a:p>
           <a:p/>
@@ -14208,7 +14208,7 @@
                 </a:solidFill>
                 <a:latin typeface="Aptos Display"/>
               </a:rPr>
-              <a:t>Hyper ou source native : une règle simple</a:t>
+              <a:t>Base d’origine ou Hyper : choisir la source</a:t>
             </a:r>
           </a:p>
         </p:txBody>
@@ -14253,7 +14253,7 @@
                 </a:solidFill>
                 <a:latin typeface="Aptos"/>
               </a:rPr>
-              <a:t>Politique PBIP automatique ; la taille Hyper est mesurée décompressée.</a:t>
+              <a:t>Même source Tableau : base explicite complète prioritaire ; sinon Hyper.</a:t>
             </a:r>
           </a:p>
         </p:txBody>
@@ -14357,6 +14357,96 @@
         <p:spPr>
           <a:xfrm>
             <a:off x="594360" y="2313432"/>
+            <a:ext cx="5303520" cy="320040"/>
+          </a:xfrm>
+          <a:prstGeom prst="roundRect">
+            <a:avLst>
+              <a:gd name="adj" fmla="val 12000"/>
+            </a:avLst>
+          </a:prstGeom>
+          <a:solidFill>
+            <a:srgbClr val="E0F1EF"/>
+          </a:solidFill>
+          <a:ln>
+            <a:noFill/>
+          </a:ln>
+        </p:spPr>
+        <p:style>
+          <a:lnRef idx="1">
+            <a:schemeClr val="accent1"/>
+          </a:lnRef>
+          <a:fillRef idx="3">
+            <a:schemeClr val="accent1"/>
+          </a:fillRef>
+          <a:effectRef idx="2">
+            <a:schemeClr val="accent1"/>
+          </a:effectRef>
+          <a:fontRef idx="minor">
+            <a:schemeClr val="lt1"/>
+          </a:fontRef>
+        </p:style>
+        <p:txBody>
+          <a:bodyPr rtlCol="0" anchor="ctr"/>
+          <a:lstStyle/>
+          <a:p>
+            <a:pPr algn="ctr"/>
+          </a:p>
+        </p:txBody>
+      </p:sp>
+      <p:sp>
+        <p:nvSpPr>
+          <p:cNvPr id="8" name="TextBox 7"/>
+          <p:cNvSpPr txBox="1"/>
+          <p:nvPr/>
+        </p:nvSpPr>
+        <p:spPr>
+          <a:xfrm>
+            <a:off x="685800" y="2350008"/>
+            <a:ext cx="5120640" cy="219456"/>
+          </a:xfrm>
+          <a:prstGeom prst="rect">
+            <a:avLst/>
+          </a:prstGeom>
+          <a:noFill/>
+        </p:spPr>
+        <p:txBody>
+          <a:bodyPr wrap="square" lIns="0" rIns="0" tIns="0" bIns="0" anchor="t">
+            <a:noAutofit/>
+          </a:bodyPr>
+          <a:lstStyle/>
+          <a:p>
+            <a:pPr algn="l">
+              <a:lnSpc>
+                <a:spcPct val="108000"/>
+              </a:lnSpc>
+              <a:spcBef>
+                <a:spcPts val="0"/>
+              </a:spcBef>
+              <a:spcAft>
+                <a:spcPts val="500"/>
+              </a:spcAft>
+            </a:pPr>
+            <a:r>
+              <a:rPr sz="1100" b="1">
+                <a:solidFill>
+                  <a:srgbClr val="007F79"/>
+                </a:solidFill>
+                <a:latin typeface="Aptos"/>
+              </a:rPr>
+              <a:t>1 — BASE D’ORIGINE SI ÉLIGIBLE</a:t>
+            </a:r>
+          </a:p>
+        </p:txBody>
+      </p:sp>
+      <p:sp>
+        <p:nvSpPr>
+          <p:cNvPr id="9" name="Rounded Rectangle 8"/>
+          <p:cNvSpPr/>
+          <p:nvPr/>
+        </p:nvSpPr>
+        <p:spPr>
+          <a:xfrm>
+            <a:off x="6263640" y="2313432"/>
             <a:ext cx="5303520" cy="320040"/>
           </a:xfrm>
           <a:prstGeom prst="roundRect">
@@ -14395,13 +14485,13 @@
       </p:sp>
       <p:sp>
         <p:nvSpPr>
-          <p:cNvPr id="8" name="TextBox 7"/>
-          <p:cNvSpPr txBox="1"/>
-          <p:nvPr/>
-        </p:nvSpPr>
-        <p:spPr>
-          <a:xfrm>
-            <a:off x="685800" y="2350008"/>
+          <p:cNvPr id="10" name="TextBox 9"/>
+          <p:cNvSpPr txBox="1"/>
+          <p:nvPr/>
+        </p:nvSpPr>
+        <p:spPr>
+          <a:xfrm>
+            <a:off x="6355079" y="2350008"/>
             <a:ext cx="5120640" cy="219456"/>
           </a:xfrm>
           <a:prstGeom prst="rect">
@@ -14433,21 +14523,21 @@
                 </a:solidFill>
                 <a:latin typeface="Aptos"/>
               </a:rPr>
-              <a:t>HYPER PRÉSENT : EXPORT DU SNAPSHOT</a:t>
-            </a:r>
-          </a:p>
-        </p:txBody>
-      </p:sp>
-      <p:sp>
-        <p:nvSpPr>
-          <p:cNvPr id="9" name="Rounded Rectangle 8"/>
+              <a:t>2 — SINON : HYPER CONSERVÉ</a:t>
+            </a:r>
+          </a:p>
+        </p:txBody>
+      </p:sp>
+      <p:sp>
+        <p:nvSpPr>
+          <p:cNvPr id="11" name="Rounded Rectangle 10"/>
           <p:cNvSpPr/>
           <p:nvPr/>
         </p:nvSpPr>
         <p:spPr>
           <a:xfrm>
-            <a:off x="6263640" y="2313432"/>
-            <a:ext cx="5303520" cy="320040"/>
+            <a:off x="594360" y="2916936"/>
+            <a:ext cx="5303520" cy="1261872"/>
           </a:xfrm>
           <a:prstGeom prst="roundRect">
             <a:avLst>
@@ -14455,7 +14545,7 @@
             </a:avLst>
           </a:prstGeom>
           <a:solidFill>
-            <a:srgbClr val="E0F1EF"/>
+            <a:srgbClr val="007F79"/>
           </a:solidFill>
           <a:ln>
             <a:noFill/>
@@ -14485,58 +14575,103 @@
       </p:sp>
       <p:sp>
         <p:nvSpPr>
-          <p:cNvPr id="10" name="TextBox 9"/>
-          <p:cNvSpPr txBox="1"/>
-          <p:nvPr/>
-        </p:nvSpPr>
-        <p:spPr>
-          <a:xfrm>
-            <a:off x="6355079" y="2350008"/>
-            <a:ext cx="5120640" cy="219456"/>
-          </a:xfrm>
-          <a:prstGeom prst="rect">
-            <a:avLst/>
-          </a:prstGeom>
-          <a:noFill/>
-        </p:spPr>
-        <p:txBody>
-          <a:bodyPr wrap="square" lIns="0" rIns="0" tIns="0" bIns="0" anchor="t">
-            <a:noAutofit/>
-          </a:bodyPr>
-          <a:lstStyle/>
-          <a:p>
-            <a:pPr algn="l">
-              <a:lnSpc>
-                <a:spcPct val="108000"/>
-              </a:lnSpc>
-              <a:spcBef>
-                <a:spcPts val="0"/>
-              </a:spcBef>
-              <a:spcAft>
-                <a:spcPts val="500"/>
-              </a:spcAft>
-            </a:pPr>
-            <a:r>
-              <a:rPr sz="1100" b="1">
-                <a:solidFill>
-                  <a:srgbClr val="007F79"/>
-                </a:solidFill>
-                <a:latin typeface="Aptos"/>
-              </a:rPr>
-              <a:t>SANS HYPER : SOURCE CONSERVÉE</a:t>
-            </a:r>
-          </a:p>
-        </p:txBody>
-      </p:sp>
-      <p:sp>
-        <p:nvSpPr>
-          <p:cNvPr id="11" name="Rounded Rectangle 10"/>
+          <p:cNvPr id="12" name="TextBox 11"/>
+          <p:cNvSpPr txBox="1"/>
+          <p:nvPr/>
+        </p:nvSpPr>
+        <p:spPr>
+          <a:xfrm>
+            <a:off x="758952" y="3090672"/>
+            <a:ext cx="4974336" cy="402336"/>
+          </a:xfrm>
+          <a:prstGeom prst="rect">
+            <a:avLst/>
+          </a:prstGeom>
+          <a:noFill/>
+        </p:spPr>
+        <p:txBody>
+          <a:bodyPr wrap="square" lIns="0" rIns="0" tIns="0" bIns="0" anchor="t">
+            <a:noAutofit/>
+          </a:bodyPr>
+          <a:lstStyle/>
+          <a:p>
+            <a:pPr algn="ctr">
+              <a:lnSpc>
+                <a:spcPct val="108000"/>
+              </a:lnSpc>
+              <a:spcBef>
+                <a:spcPts val="0"/>
+              </a:spcBef>
+              <a:spcAft>
+                <a:spcPts val="500"/>
+              </a:spcAft>
+            </a:pPr>
+            <a:r>
+              <a:rPr sz="1900" b="1">
+                <a:solidFill>
+                  <a:srgbClr val="FFFFFF"/>
+                </a:solidFill>
+                <a:latin typeface="Aptos"/>
+              </a:rPr>
+              <a:t>DirectQuery si compatible</a:t>
+            </a:r>
+          </a:p>
+        </p:txBody>
+      </p:sp>
+      <p:sp>
+        <p:nvSpPr>
+          <p:cNvPr id="13" name="TextBox 12"/>
+          <p:cNvSpPr txBox="1"/>
+          <p:nvPr/>
+        </p:nvSpPr>
+        <p:spPr>
+          <a:xfrm>
+            <a:off x="758952" y="3593591"/>
+            <a:ext cx="4974336" cy="521207"/>
+          </a:xfrm>
+          <a:prstGeom prst="rect">
+            <a:avLst/>
+          </a:prstGeom>
+          <a:noFill/>
+        </p:spPr>
+        <p:txBody>
+          <a:bodyPr wrap="square" lIns="0" rIns="0" tIns="0" bIns="0" anchor="t">
+            <a:noAutofit/>
+          </a:bodyPr>
+          <a:lstStyle/>
+          <a:p>
+            <a:pPr algn="ctr">
+              <a:lnSpc>
+                <a:spcPct val="108000"/>
+              </a:lnSpc>
+              <a:spcBef>
+                <a:spcPts val="0"/>
+              </a:spcBef>
+              <a:spcAft>
+                <a:spcPts val="500"/>
+              </a:spcAft>
+            </a:pPr>
+            <a:r>
+              <a:rPr sz="1400" b="0">
+                <a:solidFill>
+                  <a:srgbClr val="FFFFFF"/>
+                </a:solidFill>
+                <a:latin typeface="Aptos"/>
+              </a:rPr>
+              <a:t>Import si forcé ou si incompatible</a:t>
+            </a:r>
+          </a:p>
+        </p:txBody>
+      </p:sp>
+      <p:sp>
+        <p:nvSpPr>
+          <p:cNvPr id="14" name="Rounded Rectangle 13"/>
           <p:cNvSpPr/>
           <p:nvPr/>
         </p:nvSpPr>
         <p:spPr>
           <a:xfrm>
-            <a:off x="594360" y="2916936"/>
+            <a:off x="6263640" y="2916936"/>
             <a:ext cx="2468880" cy="1261872"/>
           </a:xfrm>
           <a:prstGeom prst="roundRect">
@@ -14545,7 +14680,7 @@
             </a:avLst>
           </a:prstGeom>
           <a:solidFill>
-            <a:srgbClr val="C85A17"/>
+            <a:srgbClr val="A3430C"/>
           </a:solidFill>
           <a:ln>
             <a:noFill/>
@@ -14575,13 +14710,13 @@
       </p:sp>
       <p:sp>
         <p:nvSpPr>
-          <p:cNvPr id="12" name="TextBox 11"/>
-          <p:cNvSpPr txBox="1"/>
-          <p:nvPr/>
-        </p:nvSpPr>
-        <p:spPr>
-          <a:xfrm>
-            <a:off x="758952" y="3090672"/>
+          <p:cNvPr id="15" name="TextBox 14"/>
+          <p:cNvSpPr txBox="1"/>
+          <p:nvPr/>
+        </p:nvSpPr>
+        <p:spPr>
+          <a:xfrm>
+            <a:off x="6428231" y="3090672"/>
             <a:ext cx="2139696" cy="402336"/>
           </a:xfrm>
           <a:prstGeom prst="rect">
@@ -14620,13 +14755,13 @@
       </p:sp>
       <p:sp>
         <p:nvSpPr>
-          <p:cNvPr id="13" name="TextBox 12"/>
-          <p:cNvSpPr txBox="1"/>
-          <p:nvPr/>
-        </p:nvSpPr>
-        <p:spPr>
-          <a:xfrm>
-            <a:off x="758952" y="3593591"/>
+          <p:cNvPr id="16" name="TextBox 15"/>
+          <p:cNvSpPr txBox="1"/>
+          <p:nvPr/>
+        </p:nvSpPr>
+        <p:spPr>
+          <a:xfrm>
+            <a:off x="6428231" y="3593591"/>
             <a:ext cx="2139696" cy="521207"/>
           </a:xfrm>
           <a:prstGeom prst="rect">
@@ -14665,13 +14800,13 @@
       </p:sp>
       <p:sp>
         <p:nvSpPr>
-          <p:cNvPr id="14" name="Rounded Rectangle 13"/>
+          <p:cNvPr id="17" name="Rounded Rectangle 16"/>
           <p:cNvSpPr/>
           <p:nvPr/>
         </p:nvSpPr>
         <p:spPr>
           <a:xfrm>
-            <a:off x="3429000" y="2916936"/>
+            <a:off x="9098280" y="2916936"/>
             <a:ext cx="2468880" cy="1261872"/>
           </a:xfrm>
           <a:prstGeom prst="roundRect">
@@ -14710,13 +14845,13 @@
       </p:sp>
       <p:sp>
         <p:nvSpPr>
-          <p:cNvPr id="15" name="TextBox 14"/>
-          <p:cNvSpPr txBox="1"/>
-          <p:nvPr/>
-        </p:nvSpPr>
-        <p:spPr>
-          <a:xfrm>
-            <a:off x="3593592" y="3090672"/>
+          <p:cNvPr id="18" name="TextBox 17"/>
+          <p:cNvSpPr txBox="1"/>
+          <p:nvPr/>
+        </p:nvSpPr>
+        <p:spPr>
+          <a:xfrm>
+            <a:off x="9262872" y="3090672"/>
             <a:ext cx="2139696" cy="402336"/>
           </a:xfrm>
           <a:prstGeom prst="rect">
@@ -14755,13 +14890,13 @@
       </p:sp>
       <p:sp>
         <p:nvSpPr>
-          <p:cNvPr id="16" name="TextBox 15"/>
-          <p:cNvSpPr txBox="1"/>
-          <p:nvPr/>
-        </p:nvSpPr>
-        <p:spPr>
-          <a:xfrm>
-            <a:off x="3593592" y="3593591"/>
+          <p:cNvPr id="19" name="TextBox 18"/>
+          <p:cNvSpPr txBox="1"/>
+          <p:nvPr/>
+        </p:nvSpPr>
+        <p:spPr>
+          <a:xfrm>
+            <a:off x="9262872" y="3593591"/>
             <a:ext cx="2139696" cy="521207"/>
           </a:xfrm>
           <a:prstGeom prst="rect">
@@ -14800,141 +14935,6 @@
       </p:sp>
       <p:sp>
         <p:nvSpPr>
-          <p:cNvPr id="17" name="Rounded Rectangle 16"/>
-          <p:cNvSpPr/>
-          <p:nvPr/>
-        </p:nvSpPr>
-        <p:spPr>
-          <a:xfrm>
-            <a:off x="6263640" y="2916936"/>
-            <a:ext cx="5303520" cy="1261872"/>
-          </a:xfrm>
-          <a:prstGeom prst="roundRect">
-            <a:avLst>
-              <a:gd name="adj" fmla="val 12000"/>
-            </a:avLst>
-          </a:prstGeom>
-          <a:solidFill>
-            <a:srgbClr val="007F79"/>
-          </a:solidFill>
-          <a:ln>
-            <a:noFill/>
-          </a:ln>
-        </p:spPr>
-        <p:style>
-          <a:lnRef idx="1">
-            <a:schemeClr val="accent1"/>
-          </a:lnRef>
-          <a:fillRef idx="3">
-            <a:schemeClr val="accent1"/>
-          </a:fillRef>
-          <a:effectRef idx="2">
-            <a:schemeClr val="accent1"/>
-          </a:effectRef>
-          <a:fontRef idx="minor">
-            <a:schemeClr val="lt1"/>
-          </a:fontRef>
-        </p:style>
-        <p:txBody>
-          <a:bodyPr rtlCol="0" anchor="ctr"/>
-          <a:lstStyle/>
-          <a:p>
-            <a:pPr algn="ctr"/>
-          </a:p>
-        </p:txBody>
-      </p:sp>
-      <p:sp>
-        <p:nvSpPr>
-          <p:cNvPr id="18" name="TextBox 17"/>
-          <p:cNvSpPr txBox="1"/>
-          <p:nvPr/>
-        </p:nvSpPr>
-        <p:spPr>
-          <a:xfrm>
-            <a:off x="6428231" y="3090672"/>
-            <a:ext cx="4974336" cy="402336"/>
-          </a:xfrm>
-          <a:prstGeom prst="rect">
-            <a:avLst/>
-          </a:prstGeom>
-          <a:noFill/>
-        </p:spPr>
-        <p:txBody>
-          <a:bodyPr wrap="square" lIns="0" rIns="0" tIns="0" bIns="0" anchor="t">
-            <a:noAutofit/>
-          </a:bodyPr>
-          <a:lstStyle/>
-          <a:p>
-            <a:pPr algn="ctr">
-              <a:lnSpc>
-                <a:spcPct val="108000"/>
-              </a:lnSpc>
-              <a:spcBef>
-                <a:spcPts val="0"/>
-              </a:spcBef>
-              <a:spcAft>
-                <a:spcPts val="500"/>
-              </a:spcAft>
-            </a:pPr>
-            <a:r>
-              <a:rPr sz="1900" b="1">
-                <a:solidFill>
-                  <a:srgbClr val="FFFFFF"/>
-                </a:solidFill>
-                <a:latin typeface="Aptos"/>
-              </a:rPr>
-              <a:t>DirectQuery si compatible</a:t>
-            </a:r>
-          </a:p>
-        </p:txBody>
-      </p:sp>
-      <p:sp>
-        <p:nvSpPr>
-          <p:cNvPr id="19" name="TextBox 18"/>
-          <p:cNvSpPr txBox="1"/>
-          <p:nvPr/>
-        </p:nvSpPr>
-        <p:spPr>
-          <a:xfrm>
-            <a:off x="6428231" y="3593591"/>
-            <a:ext cx="4974336" cy="521207"/>
-          </a:xfrm>
-          <a:prstGeom prst="rect">
-            <a:avLst/>
-          </a:prstGeom>
-          <a:noFill/>
-        </p:spPr>
-        <p:txBody>
-          <a:bodyPr wrap="square" lIns="0" rIns="0" tIns="0" bIns="0" anchor="t">
-            <a:noAutofit/>
-          </a:bodyPr>
-          <a:lstStyle/>
-          <a:p>
-            <a:pPr algn="ctr">
-              <a:lnSpc>
-                <a:spcPct val="108000"/>
-              </a:lnSpc>
-              <a:spcBef>
-                <a:spcPts val="0"/>
-              </a:spcBef>
-              <a:spcAft>
-                <a:spcPts val="500"/>
-              </a:spcAft>
-            </a:pPr>
-            <a:r>
-              <a:rPr sz="1400" b="0">
-                <a:solidFill>
-                  <a:srgbClr val="FFFFFF"/>
-                </a:solidFill>
-                <a:latin typeface="Aptos"/>
-              </a:rPr>
-              <a:t>Sinon Import</a:t>
-            </a:r>
-          </a:p>
-        </p:txBody>
-      </p:sp>
-      <p:sp>
-        <p:nvSpPr>
           <p:cNvPr id="20" name="TextBox 19"/>
           <p:cNvSpPr txBox="1"/>
           <p:nvPr/>
@@ -14942,7 +14942,7 @@
         <p:spPr>
           <a:xfrm>
             <a:off x="658368" y="4389120"/>
-            <a:ext cx="5120640" cy="1005840"/>
+            <a:ext cx="5120640" cy="594360"/>
           </a:xfrm>
           <a:prstGeom prst="rect">
             <a:avLst/>
@@ -14973,7 +14973,7 @@
                 </a:solidFill>
                 <a:latin typeface="Aptos"/>
               </a:rPr>
-              <a:t>Export réel des données Hyper.</a:t>
+              <a:t>Aucune lecture ni export du Hyper.</a:t>
             </a:r>
           </a:p>
           <a:p>
@@ -14995,7 +14995,7 @@
                 </a:solidFill>
                 <a:latin typeface="Aptos"/>
               </a:rPr>
-              <a:t>Parquet : SDK Hyper optionnel requis.</a:t>
+              <a:t>Connexion, schéma et M ; accès à configurer.</a:t>
             </a:r>
           </a:p>
         </p:txBody>
@@ -15009,7 +15009,7 @@
         <p:spPr>
           <a:xfrm>
             <a:off x="6327648" y="4389120"/>
-            <a:ext cx="5120640" cy="1005840"/>
+            <a:ext cx="5120640" cy="594360"/>
           </a:xfrm>
           <a:prstGeom prst="rect">
             <a:avLst/>
@@ -15040,7 +15040,7 @@
                 </a:solidFill>
                 <a:latin typeface="Aptos"/>
               </a:rPr>
-              <a:t>Connexion, schéma et M uniquement.</a:t>
+              <a:t>Export complet des données Hyper.</a:t>
             </a:r>
           </a:p>
           <a:p>
@@ -15062,9 +15062,32 @@
                 </a:solidFill>
                 <a:latin typeface="Aptos"/>
               </a:rPr>
-              <a:t>Aucune extraction des données natives.</a:t>
-            </a:r>
-          </a:p>
+              <a:t>Pour Parquet : SDK Hyper requis.</a:t>
+            </a:r>
+          </a:p>
+        </p:txBody>
+      </p:sp>
+      <p:sp>
+        <p:nvSpPr>
+          <p:cNvPr id="22" name="TextBox 21"/>
+          <p:cNvSpPr txBox="1"/>
+          <p:nvPr/>
+        </p:nvSpPr>
+        <p:spPr>
+          <a:xfrm>
+            <a:off x="658368" y="5093208"/>
+            <a:ext cx="10881360" cy="256032"/>
+          </a:xfrm>
+          <a:prstGeom prst="rect">
+            <a:avLst/>
+          </a:prstGeom>
+          <a:noFill/>
+        </p:spPr>
+        <p:txBody>
+          <a:bodyPr wrap="square" lIns="0" rIns="0" tIns="0" bIns="0" anchor="t">
+            <a:noAutofit/>
+          </a:bodyPr>
+          <a:lstStyle/>
           <a:p>
             <a:pPr algn="l">
               <a:lnSpc>
@@ -15078,20 +15101,20 @@
               </a:spcAft>
             </a:pPr>
             <a:r>
-              <a:rPr sz="1600" b="0">
-                <a:solidFill>
-                  <a:srgbClr val="182630"/>
-                </a:solidFill>
-                <a:latin typeface="Aptos"/>
-              </a:rPr>
-              <a:t>Excel embarqué : copié tel quel dans Data/.</a:t>
-            </a:r>
-          </a:p>
-        </p:txBody>
-      </p:sp>
-      <p:sp>
-        <p:nvSpPr>
-          <p:cNvPr id="22" name="Rounded Rectangle 21"/>
+              <a:rPr sz="1300" b="0">
+                <a:solidFill>
+                  <a:srgbClr val="52616C"/>
+                </a:solidFill>
+                <a:latin typeface="Aptos"/>
+              </a:rPr>
+              <a:t>Exception — Excel embarqué : copié inchangé dans Data/, lié par chemin absolu.</a:t>
+            </a:r>
+          </a:p>
+        </p:txBody>
+      </p:sp>
+      <p:sp>
+        <p:nvSpPr>
+          <p:cNvPr id="23" name="Rounded Rectangle 22"/>
           <p:cNvSpPr/>
           <p:nvPr/>
         </p:nvSpPr>
@@ -15136,7 +15159,7 @@
       </p:sp>
       <p:sp>
         <p:nvSpPr>
-          <p:cNvPr id="23" name="TextBox 22"/>
+          <p:cNvPr id="24" name="TextBox 23"/>
           <p:cNvSpPr txBox="1"/>
           <p:nvPr/>
         </p:nvSpPr>
@@ -15174,7 +15197,7 @@
                 </a:solidFill>
                 <a:latin typeface="Aptos"/>
               </a:rPr>
-              <a:t>L'utilisateur garde la main : passer de DirectQuery à Import reste possible.</a:t>
+              <a:t>Source retenue : parité avec l’extrait Tableau et actualisation restent à vérifier.</a:t>
             </a:r>
           </a:p>
         </p:txBody>

</xml_diff>